<commit_message>
Se elimino un archivo innecesario
</commit_message>
<xml_diff>
--- a/presentacion_analisis_tendencias.pptx
+++ b/presentacion_analisis_tendencias.pptx
@@ -3248,14 +3248,14 @@
           <a:lstStyle/>
           <a:p>
             <a:r>
-              <a:t>Distribucion Areas Conocimiento</a:t>
+              <a:t>Distribucion Programas</a:t>
             </a:r>
           </a:p>
         </p:txBody>
       </p:sp>
       <p:pic>
         <p:nvPicPr>
-          <p:cNvPr id="3" name="Picture 2" descr="distribucion_areas_conocimiento.png"/>
+          <p:cNvPr id="3" name="Picture 2" descr="distribucion_programas.png"/>
           <p:cNvPicPr>
             <a:picLocks noChangeAspect="1"/>
           </p:cNvPicPr>
@@ -3270,7 +3270,7 @@
         <p:spPr>
           <a:xfrm>
             <a:off x="457200" y="1371600"/>
-            <a:ext cx="8229600" cy="4410417"/>
+            <a:ext cx="8229600" cy="6592773"/>
           </a:xfrm>
           <a:prstGeom prst="rect">
             <a:avLst/>
@@ -3286,6 +3286,69 @@
 </file>
 
 <file path=ppt/slides/slide4.xml><?xml version="1.0" encoding="utf-8"?>
+<p:sld xmlns:a="http://schemas.openxmlformats.org/drawingml/2006/main" xmlns:p="http://schemas.openxmlformats.org/presentationml/2006/main" xmlns:r="http://schemas.openxmlformats.org/officeDocument/2006/relationships">
+  <p:cSld>
+    <p:spTree>
+      <p:nvGrpSpPr>
+        <p:cNvPr id="1" name=""/>
+        <p:cNvGrpSpPr/>
+        <p:nvPr/>
+      </p:nvGrpSpPr>
+      <p:grpSpPr/>
+      <p:sp>
+        <p:nvSpPr>
+          <p:cNvPr id="2" name="Title 1"/>
+          <p:cNvSpPr>
+            <a:spLocks noGrp="1"/>
+          </p:cNvSpPr>
+          <p:nvPr>
+            <p:ph type="title"/>
+          </p:nvPr>
+        </p:nvSpPr>
+        <p:spPr/>
+        <p:txBody>
+          <a:bodyPr/>
+          <a:lstStyle/>
+          <a:p>
+            <a:r>
+              <a:t>Distribucion Sectores</a:t>
+            </a:r>
+          </a:p>
+        </p:txBody>
+      </p:sp>
+      <p:pic>
+        <p:nvPicPr>
+          <p:cNvPr id="3" name="Picture 2" descr="distribucion_sectores.png"/>
+          <p:cNvPicPr>
+            <a:picLocks noChangeAspect="1"/>
+          </p:cNvPicPr>
+          <p:nvPr/>
+        </p:nvPicPr>
+        <p:blipFill>
+          <a:blip r:embed="rId2"/>
+          <a:stretch>
+            <a:fillRect/>
+          </a:stretch>
+        </p:blipFill>
+        <p:spPr>
+          <a:xfrm>
+            <a:off x="457200" y="1371600"/>
+            <a:ext cx="8229600" cy="8377585"/>
+          </a:xfrm>
+          <a:prstGeom prst="rect">
+            <a:avLst/>
+          </a:prstGeom>
+        </p:spPr>
+      </p:pic>
+    </p:spTree>
+  </p:cSld>
+  <p:clrMapOvr>
+    <a:masterClrMapping/>
+  </p:clrMapOvr>
+</p:sld>
+</file>
+
+<file path=ppt/slides/slide5.xml><?xml version="1.0" encoding="utf-8"?>
 <p:sld xmlns:a="http://schemas.openxmlformats.org/drawingml/2006/main" xmlns:p="http://schemas.openxmlformats.org/presentationml/2006/main" xmlns:r="http://schemas.openxmlformats.org/officeDocument/2006/relationships">
   <p:cSld>
     <p:spTree>
@@ -3348,7 +3411,7 @@
 </p:sld>
 </file>
 
-<file path=ppt/slides/slide5.xml><?xml version="1.0" encoding="utf-8"?>
+<file path=ppt/slides/slide6.xml><?xml version="1.0" encoding="utf-8"?>
 <p:sld xmlns:a="http://schemas.openxmlformats.org/drawingml/2006/main" xmlns:p="http://schemas.openxmlformats.org/presentationml/2006/main" xmlns:r="http://schemas.openxmlformats.org/officeDocument/2006/relationships">
   <p:cSld>
     <p:spTree>
@@ -3374,14 +3437,14 @@
           <a:lstStyle/>
           <a:p>
             <a:r>
-              <a:t>Distribucion Programas</a:t>
+              <a:t>Distribucion Areas Conocimiento</a:t>
             </a:r>
           </a:p>
         </p:txBody>
       </p:sp>
       <p:pic>
         <p:nvPicPr>
-          <p:cNvPr id="3" name="Picture 2" descr="distribucion_programas.png"/>
+          <p:cNvPr id="3" name="Picture 2" descr="distribucion_areas_conocimiento.png"/>
           <p:cNvPicPr>
             <a:picLocks noChangeAspect="1"/>
           </p:cNvPicPr>
@@ -3396,70 +3459,7 @@
         <p:spPr>
           <a:xfrm>
             <a:off x="457200" y="1371600"/>
-            <a:ext cx="8229600" cy="6592773"/>
-          </a:xfrm>
-          <a:prstGeom prst="rect">
-            <a:avLst/>
-          </a:prstGeom>
-        </p:spPr>
-      </p:pic>
-    </p:spTree>
-  </p:cSld>
-  <p:clrMapOvr>
-    <a:masterClrMapping/>
-  </p:clrMapOvr>
-</p:sld>
-</file>
-
-<file path=ppt/slides/slide6.xml><?xml version="1.0" encoding="utf-8"?>
-<p:sld xmlns:a="http://schemas.openxmlformats.org/drawingml/2006/main" xmlns:p="http://schemas.openxmlformats.org/presentationml/2006/main" xmlns:r="http://schemas.openxmlformats.org/officeDocument/2006/relationships">
-  <p:cSld>
-    <p:spTree>
-      <p:nvGrpSpPr>
-        <p:cNvPr id="1" name=""/>
-        <p:cNvGrpSpPr/>
-        <p:nvPr/>
-      </p:nvGrpSpPr>
-      <p:grpSpPr/>
-      <p:sp>
-        <p:nvSpPr>
-          <p:cNvPr id="2" name="Title 1"/>
-          <p:cNvSpPr>
-            <a:spLocks noGrp="1"/>
-          </p:cNvSpPr>
-          <p:nvPr>
-            <p:ph type="title"/>
-          </p:nvPr>
-        </p:nvSpPr>
-        <p:spPr/>
-        <p:txBody>
-          <a:bodyPr/>
-          <a:lstStyle/>
-          <a:p>
-            <a:r>
-              <a:t>Distribucion Sectores</a:t>
-            </a:r>
-          </a:p>
-        </p:txBody>
-      </p:sp>
-      <p:pic>
-        <p:nvPicPr>
-          <p:cNvPr id="3" name="Picture 2" descr="distribucion_sectores.png"/>
-          <p:cNvPicPr>
-            <a:picLocks noChangeAspect="1"/>
-          </p:cNvPicPr>
-          <p:nvPr/>
-        </p:nvPicPr>
-        <p:blipFill>
-          <a:blip r:embed="rId2"/>
-          <a:stretch>
-            <a:fillRect/>
-          </a:stretch>
-        </p:blipFill>
-        <p:spPr>
-          <a:xfrm>
-            <a:off x="457200" y="1371600"/>
-            <a:ext cx="8229600" cy="6195135"/>
+            <a:ext cx="8229600" cy="5659860"/>
           </a:xfrm>
           <a:prstGeom prst="rect">
             <a:avLst/>

</xml_diff>